<commit_message>
fix(p3): reframe slide 8 from defensive to owning limitations
'Nothing in the Q&A should be new' could read as closing the door on
the examiner. Title now 'Limitations, deviations, and what zero-shot
means'; closing line invites discussion: 'These are the project's
limitations as I see them. All of them are disclosed in the paper, and
I am glad to discuss any of them.' Script updated to match ('Every
project has weak points. These are mine, openly.'). Deck rebuilt,
validated, slide re-rendered and inspected.
</commit_message>
<xml_diff>
--- a/deliverables/p3/Zuraiz_P3_Final.pptx
+++ b/deliverables/p3/Zuraiz_P3_Final.pptx
@@ -6744,7 +6744,7 @@
                 <a:ea typeface="Cambria" pitchFamily="34" charset="-122"/>
                 <a:cs typeface="Cambria" pitchFamily="34" charset="-120"/>
               </a:rPr>
-              <a:t>Preregistration, deviations, and what “zero-shot” means</a:t>
+              <a:t>Limitations, deviations, and what “zero-shot” means</a:t>
             </a:r>
             <a:endParaRPr lang="en-US" sz="3000" dirty="0"/>
           </a:p>
@@ -7483,7 +7483,7 @@
                 <a:ea typeface="Calibri" pitchFamily="34" charset="-122"/>
                 <a:cs typeface="Calibri" pitchFamily="34" charset="-120"/>
               </a:rPr>
-              <a:t>Nothing in the Q&amp;A should be new: every caveat and deviation on this slide is already written down in the paper.</a:t>
+              <a:t>These are the project's limitations as I see them. All of them are disclosed in the paper, and I am glad to discuss any of them.</a:t>
             </a:r>
             <a:endParaRPr lang="en-US" sz="1500" dirty="0"/>
           </a:p>

</xml_diff>

<commit_message>
chore(p3): canonical deck rebuilt with slide-6 how-block and preserved notes; drop v2
PowerPoint closed; notes re-extracted from the final saved state (no
changes since last extraction), deck regenerated under the canonical
filename, validated, v2 interim copy removed.
</commit_message>
<xml_diff>
--- a/deliverables/p3/Zuraiz_P3_Final.pptx
+++ b/deliverables/p3/Zuraiz_P3_Final.pptx
@@ -1489,7 +1489,15 @@
           <a:p>
             <a:r>
               <a:rPr lang="en-US" dirty="0"/>
-              <a:t>Good morning. My project asks whether the new generation of large audio-language models can describe audio as well as systems that were trained specifically for captioning. The one-number teaser: the best zero-shot model reaches 0.297 SPIDEr-FL on Clotho, above both trained baselines. The next ten minutes explain what that number means, where it holds, and where it breaks down.</a:t>
+              <a:t>Good morning everyone.
+My project asks one simple question. Today's big AI models can hear. But can
+they describe what they hear, as well as systems that were trained just for
+that one job?
+[point at the number]
+This number is the short answer. Point two nine seven. That's the best
+zero-shot model, and it's above both trained baselines I reproduced.
+The next ten minutes: what this number means, where it holds, and where it
+breaks down.</a:t>
             </a:r>
             <a:endParaRPr lang="en-US" dirty="0"/>
           </a:p>
@@ -1577,7 +1585,21 @@
           <a:p>
             <a:r>
               <a:rPr lang="en-US" dirty="0"/>
-              <a:t>The task is T6: LALMs versus traditional captioning, with a focus on overlapping sound. Six systems: three traditional, three zero-shot LALMs from three different vendors, so the comparison is not single-vendor. Three research questions: headline quality, polyphony, and hallucination. All hypotheses were committed in advance with bootstrap statistics.</a:t>
+              <a:t>So, the task. Audio captioning means: audio goes in, one English sentence
+comes out. Like: "Rain falls while a car passes by."
+I compare six systems. Two teams.
+[left side]
+The traditional team. AST, which only lists sound tags. That's my floor. And
+two real captioners, trained on Clotho: the official CNN14 baseline, and
+EnCLAP.
+[right side]
+The LALM team, all zero-shot. I never trained anything. Qwen, a general
+do-everything model. SALMONN, an older audio specialist. And Audio Flamingo 3
+from NVIDIA, the current state of the art. Three models, three different
+companies. So this is not a one-vendor story.
+Three questions. One: do they match the trained systems? Two: what happens on
+clips with overlapping sounds? Three: how much do they hallucinate?
+And important: all hypotheses were written down before the runs.</a:t>
             </a:r>
             <a:endParaRPr lang="en-US" dirty="0"/>
           </a:p>
@@ -1665,7 +1687,17 @@
           <a:p>
             <a:r>
               <a:rPr lang="en-US" dirty="0"/>
-              <a:t>Every system implements one contract behind a registry, so one inference loop and one scorer serve everything from a CPU baseline to a 13-billion-parameter model on an A100. Each run writes a manifest with checkpoint hashes, library versions, decode settings, and the seed. The harness is validated by reproducing the official CNN14 baseline within 0.002. All six systems completed all 1,045 clips with zero failures.</a:t>
+              <a:t>How do I make this comparison fair? One harness. Let me walk the flow, left to right.
+[trace the boxes with your hand]
+It starts with the data. The Clotho evaluation set. One thousand forty-five clips, untouched, native sample rate.
+Box two: every system implements the same tiny interface. Audio in, caption out. A small CPU model and a thirteen-billion-parameter model on an A100 look exactly the same to my pipeline.
+Box three: each run writes its predictions, plus a receipt. Checkpoint hashes, library versions, decode settings, the seed. Every number in my paper traces back to a file.
+Box four: one scorer for everyone. Same clips, same five references, same metric.
+And box five: all the analysis, the subsets, CHAIR, MACE, the statistics, reads only from those files.
+Three reasons to trust this machine.
+First: it reproduces the official baseline. Point two five nine against point two six one published. The ruler works.
+Second: the big models ran on the cluster, offline, from pre-cached checkpoints, with a fixed one-line prompt.
+Third: all six systems finished every clip. Zero failures.</a:t>
             </a:r>
             <a:endParaRPr lang="en-US" dirty="0"/>
           </a:p>
@@ -1753,7 +1785,22 @@
           <a:p>
             <a:r>
               <a:rPr lang="en-US" dirty="0"/>
-              <a:t>The answer to RQ1 is not yes or no, it is model-dependent. Every LALM clears the tagging floor by a factor of three to four, so they all describe rather than list. But Qwen and SALMONN stay below both trained captioners. Audio Flamingo 3 beats both trained systems on every metric, and its 0.297 is also above EnCLAP's published 0.291. H1 and H3 are both significant. One disclosure: our EnCLAP reproduction runs about one point below its published anchor; that is in the paper, and H1 is anchored on CNN14, which reproduces within 0.002.</a:t>
+              <a:t>Okay, the headline.
+[point at chart, bottom to top]
+The answer to question one is not yes or no. It depends on the model.
+Look at the order. Every LALM beats the tag floor by three to four times. So
+they all really describe, they don't just list.
+But. Qwen and SALMONN both stay below both trained captioners. So the claim
+"LALMs beat trained systems"? False in general.
+And then Audio Flamingo 3. It beats both trained captioners. On every single
+metric. Zero-shot. And its point two nine seven is even above EnCLAP's
+published score of point two nine one.
+The statistics hold. Hypothesis one: even the careful lower bound is point two
+eight three, clearly over the bar. Hypothesis three: paired on the same clips,
+AF3 is plus point zero seven two over SALMONN. Both very significant.
+One honest note, bottom right. My EnCLAP row runs about one point below its
+published number. That's disclosed in the paper. And my main hypothesis is
+anchored on CNN14, which reproduces almost exactly. So nothing depends on it.</a:t>
             </a:r>
             <a:endParaRPr lang="en-US" dirty="0"/>
           </a:p>
@@ -1841,7 +1888,17 @@
           <a:p>
             <a:r>
               <a:rPr lang="en-US" dirty="0"/>
-              <a:t>These are verbatim outputs for one clip, next to a human reference. AST produces a tag list. Qwen wraps everything in report framing, which no Clotho reference uses, and enumerates several events. SALMONN and the trained models produce short declaratives. Audio Flamingo 3 reads closest to the reference register, which is exactly what overlap metrics reward. And note the zipper: fluent, specific, and unsupported by the references and the audio tags. That previews the hallucination question.</a:t>
+              <a:t>Now forget numbers for a moment. This is what the systems actually say. Same
+clip, real outputs.
+The human wrote: people walking, voices, soft music.
+AST gives a tag list. Not a sentence.
+Qwen says "the audio contains..." — like a report. No human reference ever
+sounds like that. And it lists many events.
+SALMONN and EnCLAP: short, natural sentences.
+And Audio Flamingo 3 sounds exactly like a Clotho reference. That's exactly
+what the metrics reward.
+But look at the red word. A zipper. Fluent, specific... and not supported by
+the references or by the audio. Keep that zipper in mind. It comes back.</a:t>
             </a:r>
             <a:endParaRPr lang="en-US" dirty="0"/>
           </a:p>
@@ -1929,7 +1986,27 @@
           <a:p>
             <a:r>
               <a:rPr lang="en-US" dirty="0"/>
-              <a:t>We split the 1,045 clips with PANNs sound event detection: two classes co-active for at least one second. The pre-registered threshold of 0.5 was degenerate, so the pre-committed fallback rule selected 0.25: 336 polyphonic, 709 monophonic clips. Every system scores higher on the polyphonic subset, including all three non-LALM systems, which identifies it as a subset-difficulty effect: event-rich clips give captions more to match, while the monophonic bucket collects quiet ambiguous recordings. The audio-grounded MACE metric shows the same direction. This complements Professor Abesser and Harish's DCASE paper: counting and naming events gets harder with polyphony, producing a reference-like description does not.</a:t>
+              <a:t>Question two: overlapping sound. Polyphony.
+Clotho has no polyphony labels, so I built them. A sound event detector marks
+which sounds are active at every moment. If two sounds overlap for at least
+one second, the clip counts as polyphonic. The first threshold from the plan
+turned out degenerate, so a fallback rule, written down before any results,
+picked the final one. Three hundred thirty-six polyphonic clips, seven hundred
+nine monophonic.
+And here's the surprise.
+[point at chart]
+Every bar is positive. Every system scores higher on the polyphonic clips.
+Even the trained ones. Even the tag floor.
+So yes, hypothesis two formally passes for all three LALMs. But the baselines
+shift the same way. Which means: this is a property of the data, not of the
+models. Clips with more events give a caption more to match. The quiet,
+ambiguous clips are the hard ones.
+The MACE metric, which listens to the audio itself, agrees. So it's not a
+wording artifact.
+And this connects to your own work, Professor. Your DCASE paper with Harish
+showed: tagging and counting get worse with polyphony. I show: describing does
+not. Event level suffers, caption level doesn't. The two findings complement
+each other.</a:t>
             </a:r>
             <a:endParaRPr lang="en-US" dirty="0"/>
           </a:p>
@@ -2017,7 +2094,26 @@
           <a:p>
             <a:r>
               <a:rPr lang="en-US" dirty="0"/>
-              <a:t>CHAIR-audio counts caption entities supported by neither the references nor the audio tags. The four serious captioners cluster around 0.33 to 0.35; Qwen hallucinates markedly more, and AST at 0.956 is the expected validity check for an indiscriminate tag list. H4's null is retained: the best captioner does not hallucinate less per caption. The decomposition explains it: per individual mention AF3 is actually the most grounded system in the table; it simply makes more claims per caption, and each claim is a chance to be wrong. Remember the zipper. And one concrete failure mode: greedy decoding sent Qwen into a 515-word repetition loop on one clip, caught only because we retain per-clip outputs.</a:t>
+              <a:t>Question three: hallucination.
+I ported the CHAIR metric from image captioning to audio. A mentioned sound
+counts as hallucinated only if it's missing from the five human references AND
+missing from the detected audio events. Double check, so it's conservative.
+[point at chart]
+The four serious captioners cluster around point three three to point three
+five. Qwen is the outlier at point five five. And AST at point nine six is
+actually good news — a blind tag list SHOULD fail this metric. That validates
+it.
+Hypothesis four is my null result. Audio Flamingo does NOT hallucinate less
+than SALMONN. The best captioner is not the most grounded one. And I report
+that as a finding.
+But here's the interesting part. Per single claim, AF3 is the MOST grounded
+model in the whole table. Lowest rate per mention. It just makes more claims
+per caption. One point five four entities versus one point three eight. More
+claims, more chances to be wrong.
+That's the zipper, in numbers.
+And one bonus failure: greedy decoding once drove Qwen into a five-hundred-
+fifteen-word loop. "Tapped, tapped, tapped..." We caught it because every
+single output is kept.</a:t>
             </a:r>
             <a:endParaRPr lang="en-US" dirty="0"/>
           </a:p>
@@ -2105,7 +2201,18 @@
           <a:p>
             <a:r>
               <a:rPr lang="en-US" dirty="0"/>
-              <a:t>The honesty slide. All four hypotheses were committed before results, tested with BCa bootstrap and Holm correction: three supported, one null retained, and I report the null as a finding. Four disclosures, so nothing has to come out in questions. The preregistration was never formally frozen, so I treat it as a declared plan and list every deviation. Zero-shot describes my protocol, not the models' training diet: both audio specialists saw Clotho development pairs in training, which is symmetric with what the baselines trained on, and it is disclosed in the paper. The EnCLAP reproduction gap is reported openly. And the entire project is public and auditable.</a:t>
+              <a:t>Every project has weak points. These are mine, openly.
+The scoreboard: three hypotheses supported, one null, reported as a result.
+The preregistration was drafted before the runs, but never formally frozen. So
+I claim a declared plan, not confirmatory research, and I list all seven
+deviations.
+"Zero-shot" means my protocol: no fine-tuning, no examples. It does not mean
+the models never saw Clotho. Both audio specialists had Clotho training pairs
+in their corpora. Their own papers say so. That's the same data my baselines
+trained on, so it stays symmetric. And it's disclosed.
+The EnCLAP gap is reported, not tuned away. And everything, code, results,
+logbook, preregistration, is public.
+All of this is in the paper, and I'm glad to discuss any of it.</a:t>
             </a:r>
             <a:endParaRPr lang="en-US" dirty="0"/>
           </a:p>
@@ -2193,7 +2300,30 @@
           <a:p>
             <a:r>
               <a:rPr lang="en-US" dirty="0"/>
-              <a:t>Three takeaways. First, the RQ1 answer is model-dependent, and the current audio specialist genuinely beats trained captioners zero-shot. Second, the polyphony advantage is a property of the data, shared by every system, which complements the event-level picture from Professor Abesser's own work. Third, caption quality and audio grounding are different axes and evaluations should report both. Everything is reproducible from the repository. Thank you.</a:t>
+              <a:t>Three things to remember.
+The word-overlap family (RQ1 — the main scoreboard)
+CIDEr — "did you use the right words?"Counts word sequences (n-grams) shared between the model caption and the 5 human references, weighting rare informative words ("ratchet") more than filler ("a", "sound"). Used in: Table 1, RQ1. AF3: 0.460.
+SPICE — "did you name the right things?"Ignores exact wording; parses captions into little (object, attribute, relation) tuples — (rain, falls), (car, passes) — and scores tuple overlap. So CIDEr rewards phrasing, SPICE rewards content. AF3: 0.137.
+SPIDEr — just the average of CIDEr and SPICE. Words + things, one number.
+FER (fluency error rate) — fraction of a model's captions that a trained detector flags as broken English (repetitions, missing verb, half-sentence). Application: proves Qwen's low score is not garbage output — Qwen has the lowest FER in the table (0.005).
+SPIDEr-FL — the headline metric of the whole project. It's SPIDEr, but any caption flagged by the fluency detector loses 90% of its score. Why it's the headline: it's the official DCASE challenge metric, and it stops broken text from scoring. Every number in the RQ1 ordering (0.068 → 0.188 → 0.225 → 0.259 → 0.280 → 0.297) is SPIDEr-FL. H1, H2, H3 are all tested on it.
+METEOR — older word-matcher with synonym support. In Table 1 for completeness only.
+The grounding family (RQ3 — is the caption actually true?)
+CHAIR-audio — "did you mention sounds that aren't there?"Our port of a vision metric. Scan each caption for 604 known sound words; a mention is hallucinated if it's in neither the 5 references nor the detected audio events (dual criterion = conservative).
+CHAIR-s = share of captions with ≥1 invented sound (per-caption). H4 tested on this: AF3 0.347 ≈ SALMONN 0.332 → null retained.
+CHAIR-i = share of all mentions that are invented (per-claim). The twist: AF3 has the lowest CHAIR-i (0.299) — most truthful per claim, it just makes more claims (1.54 vs 1.38 per caption).
+Built-in sanity check: AST's blind tag list scores 0.956 — a hallucination metric that a dumb tagger fails is a metric that works.
+MACE — "does the caption match the audio itself?"Uses CLAP, a model that embeds sounds and sentences into the same vector space, and measures how close the caption sits to the actual recording — no word overlap involved at all. Applications in the project: (1) RQ2 cross-check — poly beats mono on MACE too (+0.021…+0.032), proving the polyphony effect isn't a wording artifact; (2) RQ3 — Qwen draws level with SALMONN on MACE despite losing badly on SPIDEr-FL, proving wording and truth are different skills. Kept secondary because its backend hears a random 7-second crop per call (±0.002 noise).
+The one answer that ties it together (if he asks "why so many metrics?")
+"Because each metric can be fooled in a different way. SPIDEr-FL can be fooled by sounding like the references without being right. CHAIR can be fooled by saying very little. MACE is noisy on its own. Used together they triangulate: AF3 wins the overlap axis, but the grounding axes show it hallucinates as often per caption as SALMONN — and only the combination of metrics could reveal that."
+And the mapping in one breath: RQ1 = SPIDEr-FL (with CIDEr/SPICE/FER as support) · RQ2 = Δ SPIDEr-FL between poly and mono, cross-checked by MACE · RQ3 = CHAIR-s (hypothesis), CHAIR-i (explanation), MACE (independent confirmation).
+One. Whether a zero-shot model beats trained captioners depends on the model.
+The current audio specialist really does.
+Two. Polyphonic clips score higher for everyone. That's the dataset, not the
+models. And it complements the event-level picture from your own work.
+Three. Caption quality and audio grounding are different axes. Measure both.
+Everything is reproducible from the repository.
+Thank you.</a:t>
             </a:r>
             <a:endParaRPr lang="en-US" dirty="0"/>
           </a:p>
@@ -6311,24 +6441,24 @@
         </p:nvSpPr>
         <p:spPr>
           <a:xfrm>
-            <a:off x="548640" y="5943600"/>
-            <a:ext cx="11064240" cy="548640"/>
-          </a:xfrm>
-          <a:prstGeom prst="rect">
-            <a:avLst/>
-          </a:prstGeom>
-          <a:noFill/>
-          <a:ln/>
-        </p:spPr>
-        <p:txBody>
-          <a:bodyPr wrap="square" lIns="0" tIns="0" rIns="0" bIns="0" rtlCol="0" anchor="ctr"/>
-          <a:lstStyle/>
-          <a:p>
-            <a:pPr indent="0" marL="0">
-              <a:buNone/>
-            </a:pPr>
-            <a:r>
-              <a:rPr lang="en-US" sz="1400" b="1" dirty="0">
+            <a:off x="548640" y="5806440"/>
+            <a:ext cx="11064240" cy="914400"/>
+          </a:xfrm>
+          <a:prstGeom prst="rect">
+            <a:avLst/>
+          </a:prstGeom>
+          <a:noFill/>
+          <a:ln/>
+        </p:spPr>
+        <p:txBody>
+          <a:bodyPr wrap="square" lIns="0" tIns="0" rIns="0" bIns="0" rtlCol="0" anchor="ctr"/>
+          <a:lstStyle/>
+          <a:p>
+            <a:pPr indent="0" marL="0">
+              <a:buNone/>
+            </a:pPr>
+            <a:r>
+              <a:rPr lang="en-US" sz="1250" b="1" dirty="0">
                 <a:solidFill>
                   <a:srgbClr val="1F2937"/>
                 </a:solidFill>
@@ -6336,9 +6466,23 @@
                 <a:ea typeface="Calibri" pitchFamily="34" charset="-122"/>
                 <a:cs typeface="Calibri" pitchFamily="34" charset="-120"/>
               </a:rPr>
-              <a:t>Split: PANNs SED, τ = 0.25 (pre-committed fallback): 336 polyphonic / 709 monophonic. Event-rich clips give captions more matchable content.</a:t>
-            </a:r>
-            <a:endParaRPr lang="en-US" sz="1400" dirty="0"/>
+              <a:t>How the split was made:  </a:t>
+            </a:r>
+            <a:pPr indent="0" marL="0">
+              <a:buNone/>
+            </a:pPr>
+            <a:r>
+              <a:rPr lang="en-US" sz="1250" dirty="0">
+                <a:solidFill>
+                  <a:srgbClr val="1F2937"/>
+                </a:solidFill>
+                <a:latin typeface="Calibri" pitchFamily="34" charset="0"/>
+                <a:ea typeface="Calibri" pitchFamily="34" charset="-122"/>
+                <a:cs typeface="Calibri" pitchFamily="34" charset="-120"/>
+              </a:rPr>
+              <a:t>a sound-event detector (PANNs) scores 527 sound classes 100 times per second; two classes overlapping for at least 1 s = polyphonic. τ = 0.25 came from a rule committed before any results: 336 polyphonic / 709 monophonic. Independent check: human references of polyphonic clips name more distinct sounds (4.5 vs 3.8).</a:t>
+            </a:r>
+            <a:endParaRPr lang="en-US" sz="1250" dirty="0"/>
           </a:p>
         </p:txBody>
       </p:sp>

</xml_diff>

<commit_message>
feat(p3): close with an open question to seed the Q&A discussion
Slide 9 now carries: 'Open question: if describing stays easy while
counting gets harder, do caption metrics measure scene understanding,
or scene summarization?' Script and notes add the spoken version with
an explicit invitation for the supervisor's view. Steers the first
minutes of Q&A onto prepared RQ2 territory and connects to the
three-level protocol.
</commit_message>
<xml_diff>
--- a/deliverables/p3/Zuraiz_P3_Final.pptx
+++ b/deliverables/p3/Zuraiz_P3_Final.pptx
@@ -2322,6 +2322,7 @@
 Two. Polyphonic clips score higher for everyone. That's the dataset, not the
 models. And it complements the event-level picture from your own work.
 Three. Caption quality and audio grounding are different axes. Measure both.
+And one question this project leaves open. I would genuinely like your view on it. If describing a scene stays easy while counting its events gets harder, what do caption metrics actually measure: scene understanding, or scene summarization? I think a joint protocol, events and captions on the same real clips, could answer that.
 Everything is reproducible from the repository.
 Thank you.</a:t>
             </a:r>
@@ -7712,7 +7713,7 @@
         </p:nvSpPr>
         <p:spPr>
           <a:xfrm>
-            <a:off x="731520" y="1600200"/>
+            <a:off x="731520" y="1554480"/>
             <a:ext cx="685800" cy="1097280"/>
           </a:xfrm>
           <a:prstGeom prst="rect">
@@ -7751,8 +7752,8 @@
         </p:nvSpPr>
         <p:spPr>
           <a:xfrm>
-            <a:off x="1600200" y="1673352"/>
-            <a:ext cx="9784080" cy="1188720"/>
+            <a:off x="1600200" y="1627632"/>
+            <a:ext cx="9784080" cy="1143000"/>
           </a:xfrm>
           <a:prstGeom prst="rect">
             <a:avLst/>
@@ -7793,7 +7794,7 @@
         </p:nvSpPr>
         <p:spPr>
           <a:xfrm>
-            <a:off x="731520" y="2926080"/>
+            <a:off x="731520" y="2788920"/>
             <a:ext cx="685800" cy="1097280"/>
           </a:xfrm>
           <a:prstGeom prst="rect">
@@ -7832,8 +7833,8 @@
         </p:nvSpPr>
         <p:spPr>
           <a:xfrm>
-            <a:off x="1600200" y="2999232"/>
-            <a:ext cx="9784080" cy="1188720"/>
+            <a:off x="1600200" y="2862072"/>
+            <a:ext cx="9784080" cy="1143000"/>
           </a:xfrm>
           <a:prstGeom prst="rect">
             <a:avLst/>
@@ -7874,7 +7875,7 @@
         </p:nvSpPr>
         <p:spPr>
           <a:xfrm>
-            <a:off x="731520" y="4251960"/>
+            <a:off x="731520" y="4023360"/>
             <a:ext cx="685800" cy="1097280"/>
           </a:xfrm>
           <a:prstGeom prst="rect">
@@ -7913,8 +7914,8 @@
         </p:nvSpPr>
         <p:spPr>
           <a:xfrm>
-            <a:off x="1600200" y="4325112"/>
-            <a:ext cx="9784080" cy="1188720"/>
+            <a:off x="1600200" y="4096512"/>
+            <a:ext cx="9784080" cy="1143000"/>
           </a:xfrm>
           <a:prstGeom prst="rect">
             <a:avLst/>
@@ -7955,8 +7956,61 @@
         </p:nvSpPr>
         <p:spPr>
           <a:xfrm>
-            <a:off x="731520" y="5806440"/>
-            <a:ext cx="10698480" cy="777240"/>
+            <a:off x="731520" y="5349240"/>
+            <a:ext cx="10698480" cy="548640"/>
+          </a:xfrm>
+          <a:prstGeom prst="rect">
+            <a:avLst/>
+          </a:prstGeom>
+          <a:noFill/>
+          <a:ln/>
+        </p:spPr>
+        <p:txBody>
+          <a:bodyPr wrap="square" lIns="0" tIns="0" rIns="0" bIns="0" rtlCol="0" anchor="ctr"/>
+          <a:lstStyle/>
+          <a:p>
+            <a:pPr indent="0" marL="0">
+              <a:buNone/>
+            </a:pPr>
+            <a:r>
+              <a:rPr lang="en-US" sz="1500" b="1" i="1" dirty="0">
+                <a:solidFill>
+                  <a:srgbClr val="CADCFC"/>
+                </a:solidFill>
+                <a:latin typeface="Calibri" pitchFamily="34" charset="0"/>
+                <a:ea typeface="Calibri" pitchFamily="34" charset="-122"/>
+                <a:cs typeface="Calibri" pitchFamily="34" charset="-120"/>
+              </a:rPr>
+              <a:t>Open question:  </a:t>
+            </a:r>
+            <a:pPr indent="0" marL="0">
+              <a:buNone/>
+            </a:pPr>
+            <a:r>
+              <a:rPr lang="en-US" sz="1500" i="1" dirty="0">
+                <a:solidFill>
+                  <a:srgbClr val="CADCFC"/>
+                </a:solidFill>
+                <a:latin typeface="Calibri" pitchFamily="34" charset="0"/>
+                <a:ea typeface="Calibri" pitchFamily="34" charset="-122"/>
+                <a:cs typeface="Calibri" pitchFamily="34" charset="-120"/>
+              </a:rPr>
+              <a:t>if describing stays easy while counting gets harder, do caption metrics measure scene understanding, or scene summarization?</a:t>
+            </a:r>
+            <a:endParaRPr lang="en-US" sz="1500" dirty="0"/>
+          </a:p>
+        </p:txBody>
+      </p:sp>
+      <p:sp>
+        <p:nvSpPr>
+          <p:cNvPr id="10" name="Text 8"/>
+          <p:cNvSpPr/>
+          <p:nvPr/>
+        </p:nvSpPr>
+        <p:spPr>
+          <a:xfrm>
+            <a:off x="731520" y="5989320"/>
+            <a:ext cx="10698480" cy="731520"/>
           </a:xfrm>
           <a:prstGeom prst="rect">
             <a:avLst/>

</xml_diff>

<commit_message>
feat(p3): add data-backed stance under the open question on slide 9
'My take from the data: summarization. Every system gains on
event-rich clips, even the tagger; the metric rewards more to
summarize, not more understanding.' Aligns with the supervisor's own
thesis that caption metrics alone cannot measure scene understanding.
Script and notes restructured: question -> stance -> invitation.
</commit_message>
<xml_diff>
--- a/deliverables/p3/Zuraiz_P3_Final.pptx
+++ b/deliverables/p3/Zuraiz_P3_Final.pptx
@@ -2323,7 +2323,9 @@
 Two. Polyphonic clips score higher for everyone. That's the dataset, not the
 models. And it complements the event-level picture from your own work.
 Three. Caption quality and audio grounding are different axes. Measure both.
-And one question this project leaves open. I would genuinely like your view on it. If describing a scene stays easy while counting its events gets harder, what do caption metrics actually measure: scene understanding, or scene summarization? I think a joint protocol, events and captions on the same real clips, could answer that.
+And one question this project leaves open. If describing a scene stays easy while counting its events gets harder, what do caption metrics actually measure: scene understanding, or scene summarization?
+My own data points to summarization. Every system gained on the event-rich clips. Even the simple tagger. So the metric rewards having more to summarize, not understanding more. Which is exactly why the two levels belong together: your event level and my caption level, on the same recordings.
+I would genuinely like your view on that.
 Everything is reproducible from the repository.
 Thank you.</a:t>
             </a:r>
@@ -7957,24 +7959,24 @@
         </p:nvSpPr>
         <p:spPr>
           <a:xfrm>
-            <a:off x="731520" y="5349240"/>
-            <a:ext cx="10698480" cy="548640"/>
-          </a:xfrm>
-          <a:prstGeom prst="rect">
-            <a:avLst/>
-          </a:prstGeom>
-          <a:noFill/>
-          <a:ln/>
-        </p:spPr>
-        <p:txBody>
-          <a:bodyPr wrap="square" lIns="0" tIns="0" rIns="0" bIns="0" rtlCol="0" anchor="ctr"/>
-          <a:lstStyle/>
-          <a:p>
-            <a:pPr indent="0" marL="0">
-              <a:buNone/>
-            </a:pPr>
-            <a:r>
-              <a:rPr lang="en-US" sz="1500" b="1" i="1" dirty="0">
+            <a:off x="731520" y="5230368"/>
+            <a:ext cx="10698480" cy="502920"/>
+          </a:xfrm>
+          <a:prstGeom prst="rect">
+            <a:avLst/>
+          </a:prstGeom>
+          <a:noFill/>
+          <a:ln/>
+        </p:spPr>
+        <p:txBody>
+          <a:bodyPr wrap="square" lIns="0" tIns="0" rIns="0" bIns="0" rtlCol="0" anchor="ctr"/>
+          <a:lstStyle/>
+          <a:p>
+            <a:pPr indent="0" marL="0">
+              <a:buNone/>
+            </a:pPr>
+            <a:r>
+              <a:rPr lang="en-US" sz="1400" b="1" i="1" dirty="0">
                 <a:solidFill>
                   <a:srgbClr val="CADCFC"/>
                 </a:solidFill>
@@ -7988,7 +7990,7 @@
               <a:buNone/>
             </a:pPr>
             <a:r>
-              <a:rPr lang="en-US" sz="1500" i="1" dirty="0">
+              <a:rPr lang="en-US" sz="1400" i="1" dirty="0">
                 <a:solidFill>
                   <a:srgbClr val="CADCFC"/>
                 </a:solidFill>
@@ -7998,7 +8000,7 @@
               </a:rPr>
               <a:t>if describing stays easy while counting gets harder, do caption metrics measure scene understanding, or scene summarization?</a:t>
             </a:r>
-            <a:endParaRPr lang="en-US" sz="1500" dirty="0"/>
+            <a:endParaRPr lang="en-US" sz="1400" dirty="0"/>
           </a:p>
         </p:txBody>
       </p:sp>
@@ -8010,27 +8012,24 @@
         </p:nvSpPr>
         <p:spPr>
           <a:xfrm>
-            <a:off x="731520" y="5989320"/>
-            <a:ext cx="10698480" cy="731520"/>
-          </a:xfrm>
-          <a:prstGeom prst="rect">
-            <a:avLst/>
-          </a:prstGeom>
-          <a:noFill/>
-          <a:ln/>
-        </p:spPr>
-        <p:txBody>
-          <a:bodyPr wrap="square" lIns="0" tIns="0" rIns="0" bIns="0" rtlCol="0" anchor="ctr"/>
-          <a:lstStyle/>
-          <a:p>
-            <a:pPr indent="0" marL="0">
-              <a:lnSpc>
-                <a:spcPct val="125000"/>
-              </a:lnSpc>
-              <a:buNone/>
-            </a:pPr>
-            <a:r>
-              <a:rPr lang="en-US" sz="1400" dirty="0">
+            <a:off x="731520" y="5760720"/>
+            <a:ext cx="10698480" cy="502920"/>
+          </a:xfrm>
+          <a:prstGeom prst="rect">
+            <a:avLst/>
+          </a:prstGeom>
+          <a:noFill/>
+          <a:ln/>
+        </p:spPr>
+        <p:txBody>
+          <a:bodyPr wrap="square" lIns="0" tIns="0" rIns="0" bIns="0" rtlCol="0" anchor="ctr"/>
+          <a:lstStyle/>
+          <a:p>
+            <a:pPr indent="0" marL="0">
+              <a:buNone/>
+            </a:pPr>
+            <a:r>
+              <a:rPr lang="en-US" sz="1350" b="1" i="1" dirty="0">
                 <a:solidFill>
                   <a:srgbClr val="CADCFC"/>
                 </a:solidFill>
@@ -8038,19 +8037,13 @@
                 <a:ea typeface="Calibri" pitchFamily="34" charset="-122"/>
                 <a:cs typeface="Calibri" pitchFamily="34" charset="-120"/>
               </a:rPr>
-              <a:t>Paper, code, results, logbook: github.com/Zuraiz270/audio-to-text-captioning-using-LALMs</a:t>
-            </a:r>
-            <a:endParaRPr lang="en-US" sz="1400" dirty="0"/>
-          </a:p>
-          <a:p>
-            <a:pPr indent="0" marL="0">
-              <a:lnSpc>
-                <a:spcPct val="125000"/>
-              </a:lnSpc>
-              <a:buNone/>
-            </a:pPr>
-            <a:r>
-              <a:rPr lang="en-US" sz="1400" dirty="0">
+              <a:t>My take from the data:  </a:t>
+            </a:r>
+            <a:pPr indent="0" marL="0">
+              <a:buNone/>
+            </a:pPr>
+            <a:r>
+              <a:rPr lang="en-US" sz="1350" i="1" dirty="0">
                 <a:solidFill>
                   <a:srgbClr val="CADCFC"/>
                 </a:solidFill>
@@ -8058,9 +8051,48 @@
                 <a:ea typeface="Calibri" pitchFamily="34" charset="-122"/>
                 <a:cs typeface="Calibri" pitchFamily="34" charset="-120"/>
               </a:rPr>
-              <a:t>Thank you.</a:t>
-            </a:r>
-            <a:endParaRPr lang="en-US" sz="1400" dirty="0"/>
+              <a:t>summarization. Every system gains on event-rich clips, even the tagger; the metric rewards more to summarize, not more understanding.</a:t>
+            </a:r>
+            <a:endParaRPr lang="en-US" sz="1350" dirty="0"/>
+          </a:p>
+        </p:txBody>
+      </p:sp>
+      <p:sp>
+        <p:nvSpPr>
+          <p:cNvPr id="11" name="Text 9"/>
+          <p:cNvSpPr/>
+          <p:nvPr/>
+        </p:nvSpPr>
+        <p:spPr>
+          <a:xfrm>
+            <a:off x="731520" y="6355080"/>
+            <a:ext cx="10698480" cy="411480"/>
+          </a:xfrm>
+          <a:prstGeom prst="rect">
+            <a:avLst/>
+          </a:prstGeom>
+          <a:noFill/>
+          <a:ln/>
+        </p:spPr>
+        <p:txBody>
+          <a:bodyPr wrap="square" lIns="0" tIns="0" rIns="0" bIns="0" rtlCol="0" anchor="ctr"/>
+          <a:lstStyle/>
+          <a:p>
+            <a:pPr indent="0" marL="0">
+              <a:buNone/>
+            </a:pPr>
+            <a:r>
+              <a:rPr lang="en-US" sz="1300" dirty="0">
+                <a:solidFill>
+                  <a:srgbClr val="CADCFC"/>
+                </a:solidFill>
+                <a:latin typeface="Calibri" pitchFamily="34" charset="0"/>
+                <a:ea typeface="Calibri" pitchFamily="34" charset="-122"/>
+                <a:cs typeface="Calibri" pitchFamily="34" charset="-120"/>
+              </a:rPr>
+              <a:t>Paper, code, results, logbook: github.com/Zuraiz270/audio-to-text-captioning-using-LALMs  ·  Thank you.</a:t>
+            </a:r>
+            <a:endParaRPr lang="en-US" sz="1300" dirty="0"/>
           </a:p>
         </p:txBody>
       </p:sp>

</xml_diff>